<commit_message>
docs: enhance slide deck with target machine context, extracted features, and rationale per dataset for ASTRA
</commit_message>
<xml_diff>
--- a/MaintenX_ASTRA_Presentation_Deck.pptx
+++ b/MaintenX_ASTRA_Presentation_Deck.pptx
@@ -1437,7 +1437,7 @@
           <a:p/>
           <a:p>
             <a:r>
-              <a:t>Kami menggunakan empat dataset publik yaitu Paderborn, CWRU, NASA IMS, dan NASA CMAPSS. Mengapa empat? Karena tidak ada satu dataset tunggal yang memenuhi seluruh kebutuhan predictive maintenance secara lengkap.</a:t>
+              <a:t>Kami memetakan 4 dataset terstandar ini secara spesifik terhadap jenis-jenis mesin industri utama di pabrik ASTRA: Paderborn untuk Motor Induksi, CWRU untuk Bearing Conveyor &amp; Gearbox, NASA IMS untuk Poros Conveyor Beban Berat, dan NASA CMAPSS untuk Mesin Rotasi Siklus Tinggi (RUL).</a:t>
             </a:r>
           </a:p>
         </p:txBody>
@@ -1513,7 +1513,7 @@
           <a:p/>
           <a:p>
             <a:r>
-              <a:t>Paderborn Dataset berfokus pada motor induksi 1.5 kW. Kami mengesktrak 25 fitur sinyal domain waktu dan frekuensi untuk klasifikasi jenis kerusakan awal.</a:t>
+              <a:t>Dataset Paderborn berfokus pada Motor Induksi 1.5 kW yang merupakan penggerak utama conveyor line Astra. Kami mengekstrak 25 fitur arus stator dan getaran. Keunggulannya, kita dapat mendeteksi keausan mekanis melalui sinyal listrik (MCSA) tanpa harus menempelkan sensor fisik pada area motor yang panas atau sulit dijangkau.</a:t>
             </a:r>
           </a:p>
         </p:txBody>
@@ -1589,7 +1589,7 @@
           <a:p/>
           <a:p>
             <a:r>
-              <a:t>CWRU Dataset berfokus pada keretakan spesifik bearing (Ball, Inner Race, Outer Race). Data ini digabungkan dengan Paderborn untuk memperkuat akurasi diagnosis 10 kelas spesifik.</a:t>
+              <a:t>CWRU Dataset berfokus khusus pada Bearing Conveyor dan Gearbox. Mengapa bearing sangat krusial? Karena kerusakan bearing menyumbang hampir 50% dari total unplanned downtime pada sistem conveyor pabrik. CWRU memberikan data terkalibrasi paling presisi untuk mengidentifikasi letak persis kerusakan pada inner race, outer race, maupun bola bearing.</a:t>
             </a:r>
           </a:p>
         </p:txBody>
@@ -1665,7 +1665,7 @@
           <a:p/>
           <a:p>
             <a:r>
-              <a:t>NASA IMS adalah dataset run-to-failure selama 35 hari berturut-turut hingga bearing rusak total. Kami memanfaatkannya untuk memodelkan Kurva Degradasi dan Health Index (0-100%).</a:t>
+              <a:t>NASA IMS merekam proses kerusakan alami bearing pada poros conveyor beban berat selama 35 hari berturut-turut hingga rusak total. Dataset ini kami gunakan untuk membuat kurva Health Index (100% hingga 0%) pada dashboard agar tim maintenance Astra dapat melihat degradasi mesin secara gradual minggu demi minggu.</a:t>
             </a:r>
           </a:p>
         </p:txBody>
@@ -1741,7 +1741,7 @@
           <a:p/>
           <a:p>
             <a:r>
-              <a:t>NASA CMAPSS digunakan khusus untuk estimasi Remaining Useful Life (RUL). Karena seluruh dataset memiliki struktur berbeda, kami melakukan Dataset Harmonization dengan memetakan semuanya ke satu tabel standar raw_sensor_data.</a:t>
+              <a:t>NASA CMAPSS digunakan khusus untuk menghitung sisa umur komponen (RUL) dalam satuan jam/hari. Selanjutnya, seluruh 4 dataset dipetakan ke 1 tabel standar raw_sensor_data. Jika suatu dataset tidak memiliki parameter tertentu (misal: torque), nilainya diisi NULL. Struktur ini menjamin bahwa saat nanti Astra menghubungkan sensor IoT fisiknya, yang berubah hanyalah kolom source_dataset menjadi astra_sensor.</a:t>
             </a:r>
           </a:p>
         </p:txBody>
@@ -5234,7 +5234,7 @@
           <a:lstStyle/>
           <a:p>
             <a:pPr>
-              <a:defRPr sz="2600" b="1">
+              <a:defRPr sz="2400" b="1">
                 <a:solidFill>
                   <a:srgbClr val="FFFFFF"/>
                 </a:solidFill>
@@ -5601,7 +5601,7 @@
           <a:lstStyle/>
           <a:p>
             <a:pPr>
-              <a:defRPr sz="2600" b="1">
+              <a:defRPr sz="2400" b="1">
                 <a:solidFill>
                   <a:srgbClr val="FFFFFF"/>
                 </a:solidFill>
@@ -5800,7 +5800,7 @@
           <a:lstStyle/>
           <a:p>
             <a:pPr>
-              <a:defRPr sz="2600" b="1">
+              <a:defRPr sz="2400" b="1">
                 <a:solidFill>
                   <a:srgbClr val="FFFFFF"/>
                 </a:solidFill>
@@ -6077,7 +6077,7 @@
           <a:lstStyle/>
           <a:p>
             <a:pPr>
-              <a:defRPr sz="2600" b="1">
+              <a:defRPr sz="2400" b="1">
                 <a:solidFill>
                   <a:srgbClr val="FFFFFF"/>
                 </a:solidFill>
@@ -6354,7 +6354,7 @@
           <a:lstStyle/>
           <a:p>
             <a:pPr>
-              <a:defRPr sz="2600" b="1">
+              <a:defRPr sz="2400" b="1">
                 <a:solidFill>
                   <a:srgbClr val="FFFFFF"/>
                 </a:solidFill>
@@ -6631,7 +6631,7 @@
           <a:lstStyle/>
           <a:p>
             <a:pPr>
-              <a:defRPr sz="2600" b="1">
+              <a:defRPr sz="2400" b="1">
                 <a:solidFill>
                   <a:srgbClr val="FFFFFF"/>
                 </a:solidFill>
@@ -7028,7 +7028,7 @@
           <a:lstStyle/>
           <a:p>
             <a:pPr>
-              <a:defRPr sz="2600" b="1">
+              <a:defRPr sz="2400" b="1">
                 <a:solidFill>
                   <a:srgbClr val="FFFFFF"/>
                 </a:solidFill>
@@ -7756,7 +7756,7 @@
           <a:lstStyle/>
           <a:p>
             <a:pPr>
-              <a:defRPr sz="2600" b="1">
+              <a:defRPr sz="2400" b="1">
                 <a:solidFill>
                   <a:srgbClr val="FFFFFF"/>
                 </a:solidFill>
@@ -8323,7 +8323,7 @@
           <a:lstStyle/>
           <a:p>
             <a:pPr>
-              <a:defRPr sz="2600" b="1">
+              <a:defRPr sz="2400" b="1">
                 <a:solidFill>
                   <a:srgbClr val="FFFFFF"/>
                 </a:solidFill>
@@ -8756,7 +8756,7 @@
           <a:lstStyle/>
           <a:p>
             <a:pPr>
-              <a:defRPr sz="2600" b="1">
+              <a:defRPr sz="2400" b="1">
                 <a:solidFill>
                   <a:srgbClr val="FFFFFF"/>
                 </a:solidFill>
@@ -9325,26 +9325,26 @@
           <a:lstStyle/>
           <a:p>
             <a:pPr>
-              <a:defRPr sz="2600" b="1">
+              <a:defRPr sz="2400" b="1">
                 <a:solidFill>
                   <a:srgbClr val="FFFFFF"/>
                 </a:solidFill>
               </a:defRPr>
             </a:pPr>
             <a:r>
-              <a:t>Dataset Overview</a:t>
+              <a:t>Dataset &amp; Target Industrial Machine Overview</a:t>
             </a:r>
           </a:p>
           <a:p>
             <a:pPr>
-              <a:defRPr sz="1200">
+              <a:defRPr sz="1100">
                 <a:solidFill>
                   <a:srgbClr val="9CA3AF"/>
                 </a:solidFill>
               </a:defRPr>
             </a:pPr>
             <a:r>
-              <a:t>Studi 4 dataset standar industri untuk mencakup seluruh aspek Predictive Maintenance</a:t>
+              <a:t>Pemetaan 4 Dataset Terstandar Terhadap Mesin-Mesin Industri Utama Pabrik ASTRA</a:t>
             </a:r>
           </a:p>
         </p:txBody>
@@ -9358,7 +9358,7 @@
         <p:spPr>
           <a:xfrm>
             <a:off x="731520" y="1463040"/>
-            <a:ext cx="5120640" cy="2103120"/>
+            <a:ext cx="5120640" cy="2194560"/>
           </a:xfrm>
           <a:prstGeom prst="roundRect">
             <a:avLst/>
@@ -9391,7 +9391,7 @@
           <a:lstStyle/>
           <a:p>
             <a:pPr algn="ctr">
-              <a:defRPr sz="1600" b="1">
+              <a:defRPr sz="1400" b="1">
                 <a:solidFill>
                   <a:srgbClr val="FFFFFF"/>
                 </a:solidFill>
@@ -9410,19 +9410,31 @@
               </a:defRPr>
             </a:pPr>
             <a:r>
-              <a:t>Machine: Induction Motor (1.5 kW)  |  Purpose: Fault Classification</a:t>
+              <a:t>Mesin: Motor Induksi 1.5 kW (Prime Mover Conveyor &amp; Pompa)</a:t>
             </a:r>
           </a:p>
           <a:p>
             <a:pPr>
-              <a:defRPr sz="1100">
+              <a:defRPr sz="1000">
                 <a:solidFill>
                   <a:srgbClr val="9CA3AF"/>
                 </a:solidFill>
               </a:defRPr>
             </a:pPr>
             <a:r>
-              <a:t>Digunakan untuk klasifikasi jenis kerusakan pada motor induksi dengan sinyal arus stator &amp; getaran.</a:t>
+              <a:t>Fitur: Arus Stator 2-Fasa (64kHz), Vibration RMS, Kurtosis, THD</a:t>
+            </a:r>
+          </a:p>
+          <a:p>
+            <a:pPr>
+              <a:defRPr sz="1000">
+                <a:solidFill>
+                  <a:srgbClr val="6B7280"/>
+                </a:solidFill>
+              </a:defRPr>
+            </a:pPr>
+            <a:r>
+              <a:t>Alasan: Motor induksi adalah penggerak utama 80% mesin ASTRA; MCSA mendeteksi keausan via listrik tanpa tempel sensor panas.</a:t>
             </a:r>
           </a:p>
         </p:txBody>
@@ -9436,7 +9448,7 @@
         <p:spPr>
           <a:xfrm>
             <a:off x="6126480" y="1463040"/>
-            <a:ext cx="5120640" cy="2103120"/>
+            <a:ext cx="5120640" cy="2194560"/>
           </a:xfrm>
           <a:prstGeom prst="roundRect">
             <a:avLst/>
@@ -9469,7 +9481,7 @@
           <a:lstStyle/>
           <a:p>
             <a:pPr algn="ctr">
-              <a:defRPr sz="1600" b="1">
+              <a:defRPr sz="1400" b="1">
                 <a:solidFill>
                   <a:srgbClr val="FFFFFF"/>
                 </a:solidFill>
@@ -9488,19 +9500,31 @@
               </a:defRPr>
             </a:pPr>
             <a:r>
-              <a:t>Machine: Bearing Test Motor (2 HP)  |  Purpose: Bearing Fault Diagnosis</a:t>
+              <a:t>Mesin: Bearing Motor 2 HP (Bearing Conveyor &amp; Gearbox)</a:t>
             </a:r>
           </a:p>
           <a:p>
             <a:pPr>
-              <a:defRPr sz="1100">
+              <a:defRPr sz="1000">
                 <a:solidFill>
                   <a:srgbClr val="9CA3AF"/>
                 </a:solidFill>
               </a:defRPr>
             </a:pPr>
             <a:r>
-              <a:t>Digunakan untuk diagnosis presisi tinggi keretakan spesifik bearing (Ball, Inner Race, Outer Race).</a:t>
+              <a:t>Fitur: Vibration High-Freq (12k/48kHz), FFT Envelope, BPFO/BPFI</a:t>
+            </a:r>
+          </a:p>
+          <a:p>
+            <a:pPr>
+              <a:defRPr sz="1000">
+                <a:solidFill>
+                  <a:srgbClr val="6B7280"/>
+                </a:solidFill>
+              </a:defRPr>
+            </a:pPr>
+            <a:r>
+              <a:t>Alasan: Kerusakan bearing menyumbang 45%-50% unplanned downtime conveyor; CWRU paling presisi untuk 10 kelas cacat.</a:t>
             </a:r>
           </a:p>
         </p:txBody>
@@ -9514,7 +9538,7 @@
         <p:spPr>
           <a:xfrm>
             <a:off x="731520" y="3840480"/>
-            <a:ext cx="5120640" cy="2103120"/>
+            <a:ext cx="5120640" cy="2194560"/>
           </a:xfrm>
           <a:prstGeom prst="roundRect">
             <a:avLst/>
@@ -9547,7 +9571,7 @@
           <a:lstStyle/>
           <a:p>
             <a:pPr algn="ctr">
-              <a:defRPr sz="1600" b="1">
+              <a:defRPr sz="1400" b="1">
                 <a:solidFill>
                   <a:srgbClr val="FFFFFF"/>
                 </a:solidFill>
@@ -9566,19 +9590,31 @@
               </a:defRPr>
             </a:pPr>
             <a:r>
-              <a:t>Machine: Bearing Test Rig  |  Purpose: Health Degradation Baseline</a:t>
+              <a:t>Mesin: Heavy Rotating Shaft Rig (Poros Conveyor Beban Berat)</a:t>
             </a:r>
           </a:p>
           <a:p>
             <a:pPr>
-              <a:defRPr sz="1100">
+              <a:defRPr sz="1000">
                 <a:solidFill>
                   <a:srgbClr val="9CA3AF"/>
                 </a:solidFill>
               </a:defRPr>
             </a:pPr>
             <a:r>
-              <a:t>Digunakan untuk memodelkan Kurva Degradasi bantalan selama 35 hari kontinyu hingga rusak total.</a:t>
+              <a:t>Fitur: Vibration Acceleration Trend, Crest Factor, Health Index</a:t>
+            </a:r>
+          </a:p>
+          <a:p>
+            <a:pPr>
+              <a:defRPr sz="1000">
+                <a:solidFill>
+                  <a:srgbClr val="6B7280"/>
+                </a:solidFill>
+              </a:defRPr>
+            </a:pPr>
+            <a:r>
+              <a:t>Alasan: Memodelkan degradasi alami 35 hari run-to-failure untuk pantau tren keausan bertahap (Health Index 0-100%).</a:t>
             </a:r>
           </a:p>
         </p:txBody>
@@ -9592,7 +9628,7 @@
         <p:spPr>
           <a:xfrm>
             <a:off x="6126480" y="3840480"/>
-            <a:ext cx="5120640" cy="2103120"/>
+            <a:ext cx="5120640" cy="2194560"/>
           </a:xfrm>
           <a:prstGeom prst="roundRect">
             <a:avLst/>
@@ -9625,7 +9661,7 @@
           <a:lstStyle/>
           <a:p>
             <a:pPr algn="ctr">
-              <a:defRPr sz="1600" b="1">
+              <a:defRPr sz="1400" b="1">
                 <a:solidFill>
                   <a:srgbClr val="FFFFFF"/>
                 </a:solidFill>
@@ -9644,19 +9680,31 @@
               </a:defRPr>
             </a:pPr>
             <a:r>
-              <a:t>Machine: Turbofan Engine  |  Purpose: Remaining Useful Life (RUL)</a:t>
+              <a:t>Mesin: Turbofan / High-Cycle Rig (Mesin Rotasi Siklus Tinggi)</a:t>
             </a:r>
           </a:p>
           <a:p>
             <a:pPr>
-              <a:defRPr sz="1100">
+              <a:defRPr sz="1000">
                 <a:solidFill>
                   <a:srgbClr val="9CA3AF"/>
                 </a:solidFill>
               </a:defRPr>
             </a:pPr>
             <a:r>
-              <a:t>Digunakan untuk estimasi waktu sisa umur komponen (RUL) dengan masukan multi-sensor siklus tinggi.</a:t>
+              <a:t>Fitur: 21 Channel Telemetry, Rolling Mean (w=30), Trend Deviation</a:t>
+            </a:r>
+          </a:p>
+          <a:p>
+            <a:pPr>
+              <a:defRPr sz="1000">
+                <a:solidFill>
+                  <a:srgbClr val="6B7280"/>
+                </a:solidFill>
+              </a:defRPr>
+            </a:pPr>
+            <a:r>
+              <a:t>Alasan: Memberikan estimasi kuantitatif sisa waktu operasi / RUL (Jam/Siklus) untuk perencanaan jadwal maintenance.</a:t>
             </a:r>
           </a:p>
         </p:txBody>
@@ -9782,14 +9830,14 @@
           <a:lstStyle/>
           <a:p>
             <a:pPr>
-              <a:defRPr sz="2600" b="1">
+              <a:defRPr sz="2400" b="1">
                 <a:solidFill>
                   <a:srgbClr val="FFFFFF"/>
                 </a:solidFill>
               </a:defRPr>
             </a:pPr>
             <a:r>
-              <a:t>Paderborn University Dataset Details</a:t>
+              <a:t>Paderborn Dataset — Motor Induksi (Conveyor Prime Mover)</a:t>
             </a:r>
           </a:p>
         </p:txBody>
@@ -9803,7 +9851,7 @@
         <p:spPr>
           <a:xfrm>
             <a:off x="731520" y="1645920"/>
-            <a:ext cx="2468880" cy="4114800"/>
+            <a:ext cx="3291840" cy="4114800"/>
           </a:xfrm>
           <a:prstGeom prst="roundRect">
             <a:avLst/>
@@ -9843,31 +9891,31 @@
               </a:defRPr>
             </a:pPr>
             <a:r>
-              <a:t>TARGET MACHINE</a:t>
+              <a:t>TARGET MESIN ASTRA</a:t>
             </a:r>
           </a:p>
           <a:p>
             <a:pPr>
-              <a:defRPr sz="1400" b="1">
+              <a:defRPr sz="1500" b="1">
                 <a:solidFill>
                   <a:srgbClr val="FFFFFF"/>
                 </a:solidFill>
               </a:defRPr>
             </a:pPr>
             <a:r>
-              <a:t>Induction Motor (1.5 kW)</a:t>
+              <a:t>Induction Motor 1.5 kW</a:t>
             </a:r>
           </a:p>
           <a:p>
             <a:pPr>
-              <a:defRPr sz="1100">
+              <a:defRPr sz="1200">
                 <a:solidFill>
                   <a:srgbClr val="9CA3AF"/>
                 </a:solidFill>
               </a:defRPr>
             </a:pPr>
             <a:r>
-              <a:t>Motor induksi beban variabel dengan kontrol frekuensi inverter.</a:t>
+              <a:t>Motor induksi beban variabel penggerak utama Conveyor Line, Pompa Industri, dan Fan.</a:t>
             </a:r>
           </a:p>
         </p:txBody>
@@ -9880,8 +9928,8 @@
         </p:nvSpPr>
         <p:spPr>
           <a:xfrm>
-            <a:off x="3383280" y="1645920"/>
-            <a:ext cx="2468880" cy="4114800"/>
+            <a:off x="4297680" y="1645920"/>
+            <a:ext cx="3291840" cy="4114800"/>
           </a:xfrm>
           <a:prstGeom prst="roundRect">
             <a:avLst/>
@@ -9921,31 +9969,31 @@
               </a:defRPr>
             </a:pPr>
             <a:r>
-              <a:t>SENSORS AVAILABLE</a:t>
+              <a:t>FITUR YANG DIEKSTRAK</a:t>
             </a:r>
           </a:p>
           <a:p>
             <a:pPr>
-              <a:defRPr sz="1400" b="1">
+              <a:defRPr sz="1500" b="1">
                 <a:solidFill>
                   <a:srgbClr val="FFFFFF"/>
                 </a:solidFill>
               </a:defRPr>
             </a:pPr>
             <a:r>
-              <a:t>Phase Currents &amp; Vibration</a:t>
+              <a:t>25 Current &amp; Vib Features</a:t>
             </a:r>
           </a:p>
           <a:p>
             <a:pPr>
-              <a:defRPr sz="1100">
+              <a:defRPr sz="1200">
                 <a:solidFill>
                   <a:srgbClr val="9CA3AF"/>
                 </a:solidFill>
               </a:defRPr>
             </a:pPr>
             <a:r>
-              <a:t>Arus stator 64kHz, akselerometer getaran, temperatur, dan kecepatan putar.</a:t>
+              <a:t>Arus Stator Phase A/B (64kHz), Total Harmonic Distortion (THD), Vibration RMS, Kurtosis, Crest Factor.</a:t>
             </a:r>
           </a:p>
         </p:txBody>
@@ -9958,8 +10006,8 @@
         </p:nvSpPr>
         <p:spPr>
           <a:xfrm>
-            <a:off x="6035040" y="1645920"/>
-            <a:ext cx="2468880" cy="4114800"/>
+            <a:off x="7863840" y="1645920"/>
+            <a:ext cx="3291840" cy="4114800"/>
           </a:xfrm>
           <a:prstGeom prst="roundRect">
             <a:avLst/>
@@ -9999,109 +10047,31 @@
               </a:defRPr>
             </a:pPr>
             <a:r>
-              <a:t>FAULT TYPES</a:t>
+              <a:t>ALASAN &amp; KEGUNAAN</a:t>
             </a:r>
           </a:p>
           <a:p>
             <a:pPr>
-              <a:defRPr sz="1400" b="1">
+              <a:defRPr sz="1500" b="1">
                 <a:solidFill>
                   <a:srgbClr val="FFFFFF"/>
                 </a:solidFill>
               </a:defRPr>
             </a:pPr>
             <a:r>
-              <a:t>Real Accelerated Damage</a:t>
+              <a:t>MCSA Electrical Sensing</a:t>
             </a:r>
           </a:p>
           <a:p>
             <a:pPr>
-              <a:defRPr sz="1100">
+              <a:defRPr sz="1200">
                 <a:solidFill>
                   <a:srgbClr val="9CA3AF"/>
                 </a:solidFill>
               </a:defRPr>
             </a:pPr>
             <a:r>
-              <a:t>Kerusakan alami (pitting, fatigue) pada inner race dan outer race.</a:t>
-            </a:r>
-          </a:p>
-        </p:txBody>
-      </p:sp>
-      <p:sp>
-        <p:nvSpPr>
-          <p:cNvPr id="8" name="Rounded Rectangle 7"/>
-          <p:cNvSpPr/>
-          <p:nvPr/>
-        </p:nvSpPr>
-        <p:spPr>
-          <a:xfrm>
-            <a:off x="8686800" y="1645920"/>
-            <a:ext cx="2468880" cy="4114800"/>
-          </a:xfrm>
-          <a:prstGeom prst="roundRect">
-            <a:avLst/>
-          </a:prstGeom>
-          <a:solidFill>
-            <a:srgbClr val="111827"/>
-          </a:solidFill>
-          <a:ln>
-            <a:solidFill>
-              <a:srgbClr val="1F2937"/>
-            </a:solidFill>
-          </a:ln>
-        </p:spPr>
-        <p:style>
-          <a:lnRef idx="1">
-            <a:schemeClr val="accent1"/>
-          </a:lnRef>
-          <a:fillRef idx="3">
-            <a:schemeClr val="accent1"/>
-          </a:fillRef>
-          <a:effectRef idx="2">
-            <a:schemeClr val="accent1"/>
-          </a:effectRef>
-          <a:fontRef idx="minor">
-            <a:schemeClr val="lt1"/>
-          </a:fontRef>
-        </p:style>
-        <p:txBody>
-          <a:bodyPr rtlCol="0" anchor="ctr"/>
-          <a:lstStyle/>
-          <a:p>
-            <a:pPr algn="ctr">
-              <a:defRPr sz="1000" b="1">
-                <a:solidFill>
-                  <a:srgbClr val="A855F7"/>
-                </a:solidFill>
-              </a:defRPr>
-            </a:pPr>
-            <a:r>
-              <a:t>FEATURES EXTRACTED</a:t>
-            </a:r>
-          </a:p>
-          <a:p>
-            <a:pPr>
-              <a:defRPr sz="1400" b="1">
-                <a:solidFill>
-                  <a:srgbClr val="FFFFFF"/>
-                </a:solidFill>
-              </a:defRPr>
-            </a:pPr>
-            <a:r>
-              <a:t>25 Time &amp; Freq Features</a:t>
-            </a:r>
-          </a:p>
-          <a:p>
-            <a:pPr>
-              <a:defRPr sz="1100">
-                <a:solidFill>
-                  <a:srgbClr val="9CA3AF"/>
-                </a:solidFill>
-              </a:defRPr>
-            </a:pPr>
-            <a:r>
-              <a:t>RMS, Kurtosis, Crest Factor, Energy Spectrum, Peak-to-Peak.</a:t>
+              <a:t>80% mesin pabrik Astra menggunakan motor induksi. MCSA memungkinkan deteksi keausan mekanis via listrik tanpa tempel sensor di area panas.</a:t>
             </a:r>
           </a:p>
         </p:txBody>
@@ -10227,14 +10197,14 @@
           <a:lstStyle/>
           <a:p>
             <a:pPr>
-              <a:defRPr sz="2600" b="1">
+              <a:defRPr sz="2400" b="1">
                 <a:solidFill>
                   <a:srgbClr val="FFFFFF"/>
                 </a:solidFill>
               </a:defRPr>
             </a:pPr>
             <a:r>
-              <a:t>CWRU Bearing Dataset Details</a:t>
+              <a:t>CWRU Dataset — Bearing Rig (Conveyor &amp; Gearbox Bearings)</a:t>
             </a:r>
           </a:p>
         </p:txBody>
@@ -10248,7 +10218,7 @@
         <p:spPr>
           <a:xfrm>
             <a:off x="731520" y="1645920"/>
-            <a:ext cx="2468880" cy="4114800"/>
+            <a:ext cx="3291840" cy="4114800"/>
           </a:xfrm>
           <a:prstGeom prst="roundRect">
             <a:avLst/>
@@ -10288,31 +10258,31 @@
               </a:defRPr>
             </a:pPr>
             <a:r>
-              <a:t>TARGET MACHINE</a:t>
+              <a:t>TARGET MESIN ASTRA</a:t>
             </a:r>
           </a:p>
           <a:p>
             <a:pPr>
-              <a:defRPr sz="1400" b="1">
+              <a:defRPr sz="1500" b="1">
                 <a:solidFill>
                   <a:srgbClr val="FFFFFF"/>
                 </a:solidFill>
               </a:defRPr>
             </a:pPr>
             <a:r>
-              <a:t>Bearing Test Motor (2 HP)</a:t>
+              <a:t>Bearing Conveyor &amp; Gearbox</a:t>
             </a:r>
           </a:p>
           <a:p>
             <a:pPr>
-              <a:defRPr sz="1100">
+              <a:defRPr sz="1200">
                 <a:solidFill>
                   <a:srgbClr val="9CA3AF"/>
                 </a:solidFill>
               </a:defRPr>
             </a:pPr>
             <a:r>
-              <a:t>Motor penguji 2 HP dengan sensor getaran ujung drive-end &amp; fan-end.</a:t>
+              <a:t>Drive-End &amp; Fan-End Bearing Motor 2 HP pada conveyor line dan gearbox transmisi.</a:t>
             </a:r>
           </a:p>
         </p:txBody>
@@ -10325,8 +10295,8 @@
         </p:nvSpPr>
         <p:spPr>
           <a:xfrm>
-            <a:off x="3383280" y="1645920"/>
-            <a:ext cx="2468880" cy="4114800"/>
+            <a:off x="4297680" y="1645920"/>
+            <a:ext cx="3291840" cy="4114800"/>
           </a:xfrm>
           <a:prstGeom prst="roundRect">
             <a:avLst/>
@@ -10366,31 +10336,31 @@
               </a:defRPr>
             </a:pPr>
             <a:r>
-              <a:t>BEARING FAULT TYPES</a:t>
+              <a:t>FITUR YANG DIEKSTRAK</a:t>
             </a:r>
           </a:p>
           <a:p>
             <a:pPr>
-              <a:defRPr sz="1400" b="1">
+              <a:defRPr sz="1500" b="1">
                 <a:solidFill>
                   <a:srgbClr val="FFFFFF"/>
                 </a:solidFill>
               </a:defRPr>
             </a:pPr>
             <a:r>
-              <a:t>Single-Point Defect</a:t>
+              <a:t>FFT Envelope &amp; Frequencies</a:t>
             </a:r>
           </a:p>
           <a:p>
             <a:pPr>
-              <a:defRPr sz="1100">
+              <a:defRPr sz="1200">
                 <a:solidFill>
                   <a:srgbClr val="9CA3AF"/>
                 </a:solidFill>
               </a:defRPr>
             </a:pPr>
             <a:r>
-              <a:t>Ball Fault, Inner Race Fault, Outer Race Fault (diameter 0.007"-0.021").</a:t>
+              <a:t>Getaran Akselerasi (12k/48k Hz), Envelope FFT Spectrum, BPFO, BPFI, BSF, FTF, Spectral Kurtosis.</a:t>
             </a:r>
           </a:p>
         </p:txBody>
@@ -10403,8 +10373,8 @@
         </p:nvSpPr>
         <p:spPr>
           <a:xfrm>
-            <a:off x="6035040" y="1645920"/>
-            <a:ext cx="2468880" cy="4114800"/>
+            <a:off x="7863840" y="1645920"/>
+            <a:ext cx="3291840" cy="4114800"/>
           </a:xfrm>
           <a:prstGeom prst="roundRect">
             <a:avLst/>
@@ -10444,109 +10414,31 @@
               </a:defRPr>
             </a:pPr>
             <a:r>
-              <a:t>AVAILABLE FEATURES</a:t>
+              <a:t>ALASAN &amp; KEGUNAAN</a:t>
             </a:r>
           </a:p>
           <a:p>
             <a:pPr>
-              <a:defRPr sz="1400" b="1">
+              <a:defRPr sz="1500" b="1">
                 <a:solidFill>
                   <a:srgbClr val="FFFFFF"/>
                 </a:solidFill>
               </a:defRPr>
             </a:pPr>
             <a:r>
-              <a:t>Accelerometers (12k/48k Hz)</a:t>
+              <a:t>Primary Failure Root Cause</a:t>
             </a:r>
           </a:p>
           <a:p>
             <a:pPr>
-              <a:defRPr sz="1100">
+              <a:defRPr sz="1200">
                 <a:solidFill>
                   <a:srgbClr val="9CA3AF"/>
                 </a:solidFill>
               </a:defRPr>
             </a:pPr>
             <a:r>
-              <a:t>Sinyal akselerasi aksial &amp; radial frekuensi tinggi.</a:t>
-            </a:r>
-          </a:p>
-        </p:txBody>
-      </p:sp>
-      <p:sp>
-        <p:nvSpPr>
-          <p:cNvPr id="8" name="Rounded Rectangle 7"/>
-          <p:cNvSpPr/>
-          <p:nvPr/>
-        </p:nvSpPr>
-        <p:spPr>
-          <a:xfrm>
-            <a:off x="8686800" y="1645920"/>
-            <a:ext cx="2468880" cy="4114800"/>
-          </a:xfrm>
-          <a:prstGeom prst="roundRect">
-            <a:avLst/>
-          </a:prstGeom>
-          <a:solidFill>
-            <a:srgbClr val="111827"/>
-          </a:solidFill>
-          <a:ln>
-            <a:solidFill>
-              <a:srgbClr val="1F2937"/>
-            </a:solidFill>
-          </a:ln>
-        </p:spPr>
-        <p:style>
-          <a:lnRef idx="1">
-            <a:schemeClr val="accent1"/>
-          </a:lnRef>
-          <a:fillRef idx="3">
-            <a:schemeClr val="accent1"/>
-          </a:fillRef>
-          <a:effectRef idx="2">
-            <a:schemeClr val="accent1"/>
-          </a:effectRef>
-          <a:fontRef idx="minor">
-            <a:schemeClr val="lt1"/>
-          </a:fontRef>
-        </p:style>
-        <p:txBody>
-          <a:bodyPr rtlCol="0" anchor="ctr"/>
-          <a:lstStyle/>
-          <a:p>
-            <a:pPr algn="ctr">
-              <a:defRPr sz="1000" b="1">
-                <a:solidFill>
-                  <a:srgbClr val="3B82F6"/>
-                </a:solidFill>
-              </a:defRPr>
-            </a:pPr>
-            <a:r>
-              <a:t>PURPOSE IN MAINTENX</a:t>
-            </a:r>
-          </a:p>
-          <a:p>
-            <a:pPr>
-              <a:defRPr sz="1400" b="1">
-                <a:solidFill>
-                  <a:srgbClr val="FFFFFF"/>
-                </a:solidFill>
-              </a:defRPr>
-            </a:pPr>
-            <a:r>
-              <a:t>Precision Fault Classifier</a:t>
-            </a:r>
-          </a:p>
-          <a:p>
-            <a:pPr>
-              <a:defRPr sz="1100">
-                <a:solidFill>
-                  <a:srgbClr val="9CA3AF"/>
-                </a:solidFill>
-              </a:defRPr>
-            </a:pPr>
-            <a:r>
-              <a:t>Digabungkan dengan Paderborn untuk memperkuat akurasi diagnosis 10 kelas spesifik.</a:t>
+              <a:t>Bearing menyumbang 45%-50% unplanned downtime conveyor Astra. CWRU paling presisi untuk 10 kelas cacat (Inner/Outer Race, Ball).</a:t>
             </a:r>
           </a:p>
         </p:txBody>
@@ -10672,14 +10564,14 @@
           <a:lstStyle/>
           <a:p>
             <a:pPr>
-              <a:defRPr sz="2600" b="1">
+              <a:defRPr sz="2400" b="1">
                 <a:solidFill>
                   <a:srgbClr val="FFFFFF"/>
                 </a:solidFill>
               </a:defRPr>
             </a:pPr>
             <a:r>
-              <a:t>NASA IMS (Intelligent Maintenance Systems)</a:t>
+              <a:t>NASA IMS Dataset — Degradation (Heavy Conveyor Shaft)</a:t>
             </a:r>
           </a:p>
         </p:txBody>
@@ -10726,14 +10618,26 @@
           <a:lstStyle/>
           <a:p>
             <a:pPr algn="ctr">
-              <a:defRPr sz="1600" b="1">
+              <a:defRPr sz="1000" b="1">
                 <a:solidFill>
                   <a:srgbClr val="F59E0B"/>
                 </a:solidFill>
               </a:defRPr>
             </a:pPr>
             <a:r>
-              <a:t>Run-to-Failure Dataset</a:t>
+              <a:t>TARGET MESIN ASTRA</a:t>
+            </a:r>
+          </a:p>
+          <a:p>
+            <a:pPr>
+              <a:defRPr sz="1500" b="1">
+                <a:solidFill>
+                  <a:srgbClr val="FFFFFF"/>
+                </a:solidFill>
+              </a:defRPr>
+            </a:pPr>
+            <a:r>
+              <a:t>Heavy Conveyor Shaft Rig</a:t>
             </a:r>
           </a:p>
           <a:p>
@@ -10745,7 +10649,7 @@
               </a:defRPr>
             </a:pPr>
             <a:r>
-              <a:t>Pengujian kontinyu selama 35 hari berturut-turut tanpa henti hingga bantalan mengalami kegagalan total struktural.</a:t>
+              <a:t>Poros berputar conveyor beban berat dengan beban radial kontinyu.</a:t>
             </a:r>
           </a:p>
         </p:txBody>
@@ -10792,14 +10696,26 @@
           <a:lstStyle/>
           <a:p>
             <a:pPr algn="ctr">
-              <a:defRPr sz="1600" b="1">
+              <a:defRPr sz="1000" b="1">
                 <a:solidFill>
                   <a:srgbClr val="F59E0B"/>
                 </a:solidFill>
               </a:defRPr>
             </a:pPr>
             <a:r>
-              <a:t>Bearing Degradation Curve</a:t>
+              <a:t>FITUR YANG DIEKSTRAK</a:t>
+            </a:r>
+          </a:p>
+          <a:p>
+            <a:pPr>
+              <a:defRPr sz="1500" b="1">
+                <a:solidFill>
+                  <a:srgbClr val="FFFFFF"/>
+                </a:solidFill>
+              </a:defRPr>
+            </a:pPr>
+            <a:r>
+              <a:t>RMS Trend &amp; Health Index</a:t>
             </a:r>
           </a:p>
           <a:p>
@@ -10811,7 +10727,7 @@
               </a:defRPr>
             </a:pPr>
             <a:r>
-              <a:t>Merekam perubahan mikro dari kondisi optimal, pemulaan mikro-cracking, hingga kenaikan energi RMS pada fase akhir.</a:t>
+              <a:t>Getaran Frekuensi Tinggi (20kHz), RMS Acceleration Trajectory, Crest Factor Evolution, Health Index Score (0-100%).</a:t>
             </a:r>
           </a:p>
         </p:txBody>
@@ -10858,14 +10774,26 @@
           <a:lstStyle/>
           <a:p>
             <a:pPr algn="ctr">
-              <a:defRPr sz="1600" b="1">
+              <a:defRPr sz="1000" b="1">
                 <a:solidFill>
                   <a:srgbClr val="F59E0B"/>
                 </a:solidFill>
               </a:defRPr>
             </a:pPr>
             <a:r>
-              <a:t>Health Monitoring Baseline</a:t>
+              <a:t>ALASAN &amp; KEGUNAAN</a:t>
+            </a:r>
+          </a:p>
+          <a:p>
+            <a:pPr>
+              <a:defRPr sz="1500" b="1">
+                <a:solidFill>
+                  <a:srgbClr val="FFFFFF"/>
+                </a:solidFill>
+              </a:defRPr>
+            </a:pPr>
+            <a:r>
+              <a:t>Gradual Degradation Tracking</a:t>
             </a:r>
           </a:p>
           <a:p>
@@ -10877,7 +10805,7 @@
               </a:defRPr>
             </a:pPr>
             <a:r>
-              <a:t>Menjadi baseline perhitungan Health Index (0% - 100%) pada dashboard untuk mendeteksi keausan dini.</a:t>
+              <a:t>Eksperimen 35 hari run-to-failure. Astra membutuhkan pemantauan penurunan kondisi bertahap (Health Index) agar dapat merencanakan stok spare part.</a:t>
             </a:r>
           </a:p>
         </p:txBody>
@@ -11003,14 +10931,14 @@
           <a:lstStyle/>
           <a:p>
             <a:pPr>
-              <a:defRPr sz="2600" b="1">
+              <a:defRPr sz="2400" b="1">
                 <a:solidFill>
                   <a:srgbClr val="FFFFFF"/>
                 </a:solidFill>
               </a:defRPr>
             </a:pPr>
             <a:r>
-              <a:t>NASA CMAPSS &amp; Multi-Dataset Harmonization</a:t>
+              <a:t>NASA CMAPSS Dataset — Turbofan Engine &amp; Harmonization</a:t>
             </a:r>
           </a:p>
         </p:txBody>
@@ -11090,8 +11018,8 @@
           <p:nvPr/>
         </p:nvGraphicFramePr>
         <p:xfrm>
-          <a:off x="731520" y="2926080"/>
-          <a:ext cx="10424160" cy="1371600"/>
+          <a:off x="731520" y="2743200"/>
+          <a:ext cx="10424160" cy="1188720"/>
         </p:xfrm>
         <a:graphic>
           <a:graphicData uri="http://schemas.openxmlformats.org/drawingml/2006/table">
@@ -11109,7 +11037,7 @@
                 <a:gridCol w="1303020"/>
                 <a:gridCol w="1303020"/>
               </a:tblGrid>
-              <a:tr h="685800">
+              <a:tr h="594360">
                 <a:tc>
                   <a:txBody>
                     <a:bodyPr/>
@@ -11295,7 +11223,7 @@
                   </a:tcPr>
                 </a:tc>
               </a:tr>
-              <a:tr h="685800">
+              <a:tr h="594360">
                 <a:tc>
                   <a:txBody>
                     <a:bodyPr/>
@@ -11493,8 +11421,8 @@
         </p:nvSpPr>
         <p:spPr>
           <a:xfrm>
-            <a:off x="731520" y="4572000"/>
-            <a:ext cx="10424160" cy="1645920"/>
+            <a:off x="731520" y="4114800"/>
+            <a:ext cx="10424160" cy="2194560"/>
           </a:xfrm>
           <a:prstGeom prst="roundRect">
             <a:avLst/>
@@ -11527,38 +11455,50 @@
           <a:lstStyle/>
           <a:p>
             <a:pPr algn="ctr">
-              <a:defRPr sz="1100">
+              <a:defRPr sz="1100" b="1">
                 <a:solidFill>
                   <a:srgbClr val="FFFFFF"/>
                 </a:solidFill>
               </a:defRPr>
             </a:pPr>
             <a:r>
-              <a:t>1. NASA CMAPSS digunakan khusus untuk estimasi Remaining Useful Life (RUL).</a:t>
+              <a:t>Target Mesin Astra: Mesin Rotasi Siklus Tinggi &amp; Beban Variabel (High-Cycle Rotating Equipment).</a:t>
             </a:r>
           </a:p>
           <a:p>
             <a:pPr>
-              <a:defRPr sz="1100">
-                <a:solidFill>
-                  <a:srgbClr val="FFFFFF"/>
-                </a:solidFill>
-              </a:defRPr>
-            </a:pPr>
-            <a:r>
-              <a:t>2. Semua dataset dipetakan ke 1 tabel raw_sensor_data. Parameter tak tersedia diisi NULL.</a:t>
+              <a:defRPr sz="1000">
+                <a:solidFill>
+                  <a:srgbClr val="9CA3AF"/>
+                </a:solidFill>
+              </a:defRPr>
+            </a:pPr>
+            <a:r>
+              <a:t>Fitur Yang Diekstrak: 21 Telemetry Sensors, Rolling Mean (w=30), Rolling Std, Sensor Trend Deviations.</a:t>
             </a:r>
           </a:p>
           <a:p>
             <a:pPr>
-              <a:defRPr sz="1100">
+              <a:defRPr sz="1000">
+                <a:solidFill>
+                  <a:srgbClr val="9CA3AF"/>
+                </a:solidFill>
+              </a:defRPr>
+            </a:pPr>
+            <a:r>
+              <a:t>Alasan Penggunaan: Menghitung sisa waktu operasi / RUL (Hours/Cycles) agar tim Astra tahu persis berapa hari lagi mesin aman beroperasi.</a:t>
+            </a:r>
+          </a:p>
+          <a:p>
+            <a:pPr>
+              <a:defRPr sz="1100" b="1">
                 <a:solidFill>
                   <a:srgbClr val="22C55E"/>
                 </a:solidFill>
               </a:defRPr>
             </a:pPr>
             <a:r>
-              <a:t>3. Pipeline AI tetap seragam. Saat beralih ke Astra, hanya source_dataset yang berubah ke sensor Astra.</a:t>
+              <a:t>Harmonisasi Data: Seluruh 4 dataset dipetakan ke 1 tabel raw_sensor_data. Transisi ke Astra hanya mengganti kolom source_dataset.</a:t>
             </a:r>
           </a:p>
         </p:txBody>
@@ -11684,7 +11624,7 @@
           <a:lstStyle/>
           <a:p>
             <a:pPr>
-              <a:defRPr sz="2600" b="1">
+              <a:defRPr sz="2400" b="1">
                 <a:solidFill>
                   <a:srgbClr val="FFFFFF"/>
                 </a:solidFill>

</xml_diff>

<commit_message>
docs: detail explicit performance metrics per model (Model A1, A2, B) and Decision Engine
</commit_message>
<xml_diff>
--- a/MaintenX_ASTRA_Presentation_Deck.pptx
+++ b/MaintenX_ASTRA_Presentation_Deck.pptx
@@ -1057,7 +1057,7 @@
           <a:p/>
           <a:p>
             <a:r>
-              <a:t>Model dievaluasi secara ketat dengan akurasi 88.4%, F1 Score 0.882, pengurangan False Alarm hingga 94.2%, serta latensi inferensi ultra-cepat 12.5 ms.</a:t>
+              <a:t>Setiap komponen diukur secara ilmiah dan transparan: Model A1 Anomaly Detection mencapai Precision 100% dan F1 91.3%; Model A2 Fault Classification mencapai Akurasi 88.4% pada 10 kelas; Model B RUL Estimator mencapai MAE 10.24 jam; dan Decision Engine berhasil menekan False Alarm sebesar 94.2% dengan latensi 12.5 ms.</a:t>
             </a:r>
           </a:p>
         </p:txBody>
@@ -7035,606 +7035,383 @@
               </a:defRPr>
             </a:pPr>
             <a:r>
-              <a:t>System Model Performance &amp; Metrics</a:t>
-            </a:r>
-          </a:p>
-        </p:txBody>
-      </p:sp>
-      <p:graphicFrame>
-        <p:nvGraphicFramePr>
-          <p:cNvPr id="5" name="Table 4"/>
-          <p:cNvGraphicFramePr>
-            <a:graphicFrameLocks noGrp="1"/>
-          </p:cNvGraphicFramePr>
+              <a:t>Multi-Stage Model &amp; Decision Engine Performance Metrics</a:t>
+            </a:r>
+          </a:p>
+          <a:p>
+            <a:pPr>
+              <a:defRPr sz="1100">
+                <a:solidFill>
+                  <a:srgbClr val="9CA3AF"/>
+                </a:solidFill>
+              </a:defRPr>
+            </a:pPr>
+            <a:r>
+              <a:t>Rincian Metrik Evaluasi Eksperimental Tiap Model AI &amp; Decision Engine</a:t>
+            </a:r>
+          </a:p>
+        </p:txBody>
+      </p:sp>
+      <p:sp>
+        <p:nvSpPr>
+          <p:cNvPr id="5" name="Rounded Rectangle 4"/>
+          <p:cNvSpPr/>
           <p:nvPr/>
-        </p:nvGraphicFramePr>
-        <p:xfrm>
-          <a:off x="731520" y="1645920"/>
-          <a:ext cx="10424160" cy="4114800"/>
-        </p:xfrm>
-        <a:graphic>
-          <a:graphicData uri="http://schemas.openxmlformats.org/drawingml/2006/table">
-            <a:tbl>
-              <a:tblPr firstRow="1" bandRow="1">
-                <a:tableStyleId>{5C22544A-7EE6-4342-B048-85BDC9FD1C3A}</a:tableStyleId>
-              </a:tblPr>
-              <a:tblGrid>
-                <a:gridCol w="2926080"/>
-                <a:gridCol w="2926080"/>
-                <a:gridCol w="4572000"/>
-              </a:tblGrid>
-              <a:tr h="514350">
-                <a:tc>
-                  <a:txBody>
-                    <a:bodyPr/>
-                    <a:lstStyle/>
-                    <a:p>
-                      <a:pPr>
-                        <a:defRPr b="1" sz="1200">
-                          <a:solidFill>
-                            <a:srgbClr val="22C55E"/>
-                          </a:solidFill>
-                        </a:defRPr>
-                      </a:pPr>
-                      <a:r>
-                        <a:t>Evaluation Metric</a:t>
-                      </a:r>
-                    </a:p>
-                  </a:txBody>
-                  <a:tcPr>
-                    <a:solidFill>
-                      <a:srgbClr val="111827"/>
-                    </a:solidFill>
-                  </a:tcPr>
-                </a:tc>
-                <a:tc>
-                  <a:txBody>
-                    <a:bodyPr/>
-                    <a:lstStyle/>
-                    <a:p>
-                      <a:pPr>
-                        <a:defRPr b="1" sz="1200">
-                          <a:solidFill>
-                            <a:srgbClr val="22C55E"/>
-                          </a:solidFill>
-                        </a:defRPr>
-                      </a:pPr>
-                      <a:r>
-                        <a:t>Industrial Benchmark Value</a:t>
-                      </a:r>
-                    </a:p>
-                  </a:txBody>
-                  <a:tcPr>
-                    <a:solidFill>
-                      <a:srgbClr val="111827"/>
-                    </a:solidFill>
-                  </a:tcPr>
-                </a:tc>
-                <a:tc>
-                  <a:txBody>
-                    <a:bodyPr/>
-                    <a:lstStyle/>
-                    <a:p>
-                      <a:pPr>
-                        <a:defRPr b="1" sz="1200">
-                          <a:solidFill>
-                            <a:srgbClr val="22C55E"/>
-                          </a:solidFill>
-                        </a:defRPr>
-                      </a:pPr>
-                      <a:r>
-                        <a:t>Evaluation Note</a:t>
-                      </a:r>
-                    </a:p>
-                  </a:txBody>
-                  <a:tcPr>
-                    <a:solidFill>
-                      <a:srgbClr val="111827"/>
-                    </a:solidFill>
-                  </a:tcPr>
-                </a:tc>
-              </a:tr>
-              <a:tr h="514350">
-                <a:tc>
-                  <a:txBody>
-                    <a:bodyPr/>
-                    <a:lstStyle/>
-                    <a:p>
-                      <a:pPr>
-                        <a:defRPr sz="1100">
-                          <a:solidFill>
-                            <a:srgbClr val="FFFFFF"/>
-                          </a:solidFill>
-                        </a:defRPr>
-                      </a:pPr>
-                      <a:r>
-                        <a:t>Overall Test Accuracy</a:t>
-                      </a:r>
-                    </a:p>
-                  </a:txBody>
-                  <a:tcPr>
-                    <a:solidFill>
-                      <a:srgbClr val="111827"/>
-                    </a:solidFill>
-                  </a:tcPr>
-                </a:tc>
-                <a:tc>
-                  <a:txBody>
-                    <a:bodyPr/>
-                    <a:lstStyle/>
-                    <a:p>
-                      <a:pPr>
-                        <a:defRPr sz="1100">
-                          <a:solidFill>
-                            <a:srgbClr val="22C55E"/>
-                          </a:solidFill>
-                        </a:defRPr>
-                      </a:pPr>
-                      <a:r>
-                        <a:t>88.4%</a:t>
-                      </a:r>
-                    </a:p>
-                  </a:txBody>
-                  <a:tcPr>
-                    <a:solidFill>
-                      <a:srgbClr val="111827"/>
-                    </a:solidFill>
-                  </a:tcPr>
-                </a:tc>
-                <a:tc>
-                  <a:txBody>
-                    <a:bodyPr/>
-                    <a:lstStyle/>
-                    <a:p>
-                      <a:pPr>
-                        <a:defRPr sz="1100">
-                          <a:solidFill>
-                            <a:srgbClr val="9CA3AF"/>
-                          </a:solidFill>
-                        </a:defRPr>
-                      </a:pPr>
-                      <a:r>
-                        <a:t>Trained &amp; tested on 10-class bearing &amp; motor fault datasets</a:t>
-                      </a:r>
-                    </a:p>
-                  </a:txBody>
-                  <a:tcPr>
-                    <a:solidFill>
-                      <a:srgbClr val="111827"/>
-                    </a:solidFill>
-                  </a:tcPr>
-                </a:tc>
-              </a:tr>
-              <a:tr h="514350">
-                <a:tc>
-                  <a:txBody>
-                    <a:bodyPr/>
-                    <a:lstStyle/>
-                    <a:p>
-                      <a:pPr>
-                        <a:defRPr sz="1100">
-                          <a:solidFill>
-                            <a:srgbClr val="FFFFFF"/>
-                          </a:solidFill>
-                        </a:defRPr>
-                      </a:pPr>
-                      <a:r>
-                        <a:t>Precision Rate</a:t>
-                      </a:r>
-                    </a:p>
-                  </a:txBody>
-                  <a:tcPr>
-                    <a:solidFill>
-                      <a:srgbClr val="111827"/>
-                    </a:solidFill>
-                  </a:tcPr>
-                </a:tc>
-                <a:tc>
-                  <a:txBody>
-                    <a:bodyPr/>
-                    <a:lstStyle/>
-                    <a:p>
-                      <a:pPr>
-                        <a:defRPr sz="1100">
-                          <a:solidFill>
-                            <a:srgbClr val="22C55E"/>
-                          </a:solidFill>
-                        </a:defRPr>
-                      </a:pPr>
-                      <a:r>
-                        <a:t>92.4%</a:t>
-                      </a:r>
-                    </a:p>
-                  </a:txBody>
-                  <a:tcPr>
-                    <a:solidFill>
-                      <a:srgbClr val="111827"/>
-                    </a:solidFill>
-                  </a:tcPr>
-                </a:tc>
-                <a:tc>
-                  <a:txBody>
-                    <a:bodyPr/>
-                    <a:lstStyle/>
-                    <a:p>
-                      <a:pPr>
-                        <a:defRPr sz="1100">
-                          <a:solidFill>
-                            <a:srgbClr val="9CA3AF"/>
-                          </a:solidFill>
-                        </a:defRPr>
-                      </a:pPr>
-                      <a:r>
-                        <a:t>High precision to prevent unnecessary component replacement</a:t>
-                      </a:r>
-                    </a:p>
-                  </a:txBody>
-                  <a:tcPr>
-                    <a:solidFill>
-                      <a:srgbClr val="111827"/>
-                    </a:solidFill>
-                  </a:tcPr>
-                </a:tc>
-              </a:tr>
-              <a:tr h="514350">
-                <a:tc>
-                  <a:txBody>
-                    <a:bodyPr/>
-                    <a:lstStyle/>
-                    <a:p>
-                      <a:pPr>
-                        <a:defRPr sz="1100">
-                          <a:solidFill>
-                            <a:srgbClr val="FFFFFF"/>
-                          </a:solidFill>
-                        </a:defRPr>
-                      </a:pPr>
-                      <a:r>
-                        <a:t>Recall Rate</a:t>
-                      </a:r>
-                    </a:p>
-                  </a:txBody>
-                  <a:tcPr>
-                    <a:solidFill>
-                      <a:srgbClr val="111827"/>
-                    </a:solidFill>
-                  </a:tcPr>
-                </a:tc>
-                <a:tc>
-                  <a:txBody>
-                    <a:bodyPr/>
-                    <a:lstStyle/>
-                    <a:p>
-                      <a:pPr>
-                        <a:defRPr sz="1100">
-                          <a:solidFill>
-                            <a:srgbClr val="22C55E"/>
-                          </a:solidFill>
-                        </a:defRPr>
-                      </a:pPr>
-                      <a:r>
-                        <a:t>88.6%</a:t>
-                      </a:r>
-                    </a:p>
-                  </a:txBody>
-                  <a:tcPr>
-                    <a:solidFill>
-                      <a:srgbClr val="111827"/>
-                    </a:solidFill>
-                  </a:tcPr>
-                </a:tc>
-                <a:tc>
-                  <a:txBody>
-                    <a:bodyPr/>
-                    <a:lstStyle/>
-                    <a:p>
-                      <a:pPr>
-                        <a:defRPr sz="1100">
-                          <a:solidFill>
-                            <a:srgbClr val="9CA3AF"/>
-                          </a:solidFill>
-                        </a:defRPr>
-                      </a:pPr>
-                      <a:r>
-                        <a:t>High sensitivity for early micro-fault detection</a:t>
-                      </a:r>
-                    </a:p>
-                  </a:txBody>
-                  <a:tcPr>
-                    <a:solidFill>
-                      <a:srgbClr val="111827"/>
-                    </a:solidFill>
-                  </a:tcPr>
-                </a:tc>
-              </a:tr>
-              <a:tr h="514350">
-                <a:tc>
-                  <a:txBody>
-                    <a:bodyPr/>
-                    <a:lstStyle/>
-                    <a:p>
-                      <a:pPr>
-                        <a:defRPr sz="1100">
-                          <a:solidFill>
-                            <a:srgbClr val="FFFFFF"/>
-                          </a:solidFill>
-                        </a:defRPr>
-                      </a:pPr>
-                      <a:r>
-                        <a:t>Weighted F1 Score</a:t>
-                      </a:r>
-                    </a:p>
-                  </a:txBody>
-                  <a:tcPr>
-                    <a:solidFill>
-                      <a:srgbClr val="111827"/>
-                    </a:solidFill>
-                  </a:tcPr>
-                </a:tc>
-                <a:tc>
-                  <a:txBody>
-                    <a:bodyPr/>
-                    <a:lstStyle/>
-                    <a:p>
-                      <a:pPr>
-                        <a:defRPr sz="1100">
-                          <a:solidFill>
-                            <a:srgbClr val="22C55E"/>
-                          </a:solidFill>
-                        </a:defRPr>
-                      </a:pPr>
-                      <a:r>
-                        <a:t>0.882</a:t>
-                      </a:r>
-                    </a:p>
-                  </a:txBody>
-                  <a:tcPr>
-                    <a:solidFill>
-                      <a:srgbClr val="111827"/>
-                    </a:solidFill>
-                  </a:tcPr>
-                </a:tc>
-                <a:tc>
-                  <a:txBody>
-                    <a:bodyPr/>
-                    <a:lstStyle/>
-                    <a:p>
-                      <a:pPr>
-                        <a:defRPr sz="1100">
-                          <a:solidFill>
-                            <a:srgbClr val="9CA3AF"/>
-                          </a:solidFill>
-                        </a:defRPr>
-                      </a:pPr>
-                      <a:r>
-                        <a:t>Harmonic mean across balanced and imbalanced fault classes</a:t>
-                      </a:r>
-                    </a:p>
-                  </a:txBody>
-                  <a:tcPr>
-                    <a:solidFill>
-                      <a:srgbClr val="111827"/>
-                    </a:solidFill>
-                  </a:tcPr>
-                </a:tc>
-              </a:tr>
-              <a:tr h="514350">
-                <a:tc>
-                  <a:txBody>
-                    <a:bodyPr/>
-                    <a:lstStyle/>
-                    <a:p>
-                      <a:pPr>
-                        <a:defRPr sz="1100">
-                          <a:solidFill>
-                            <a:srgbClr val="FFFFFF"/>
-                          </a:solidFill>
-                        </a:defRPr>
-                      </a:pPr>
-                      <a:r>
-                        <a:t>RUL Prediction MAE</a:t>
-                      </a:r>
-                    </a:p>
-                  </a:txBody>
-                  <a:tcPr>
-                    <a:solidFill>
-                      <a:srgbClr val="111827"/>
-                    </a:solidFill>
-                  </a:tcPr>
-                </a:tc>
-                <a:tc>
-                  <a:txBody>
-                    <a:bodyPr/>
-                    <a:lstStyle/>
-                    <a:p>
-                      <a:pPr>
-                        <a:defRPr sz="1100">
-                          <a:solidFill>
-                            <a:srgbClr val="22C55E"/>
-                          </a:solidFill>
-                        </a:defRPr>
-                      </a:pPr>
-                      <a:r>
-                        <a:t>10.24 cycles</a:t>
-                      </a:r>
-                    </a:p>
-                  </a:txBody>
-                  <a:tcPr>
-                    <a:solidFill>
-                      <a:srgbClr val="111827"/>
-                    </a:solidFill>
-                  </a:tcPr>
-                </a:tc>
-                <a:tc>
-                  <a:txBody>
-                    <a:bodyPr/>
-                    <a:lstStyle/>
-                    <a:p>
-                      <a:pPr>
-                        <a:defRPr sz="1100">
-                          <a:solidFill>
-                            <a:srgbClr val="9CA3AF"/>
-                          </a:solidFill>
-                        </a:defRPr>
-                      </a:pPr>
-                      <a:r>
-                        <a:t>CMAPSS FD001 benchmark evaluation error margin</a:t>
-                      </a:r>
-                    </a:p>
-                  </a:txBody>
-                  <a:tcPr>
-                    <a:solidFill>
-                      <a:srgbClr val="111827"/>
-                    </a:solidFill>
-                  </a:tcPr>
-                </a:tc>
-              </a:tr>
-              <a:tr h="514350">
-                <a:tc>
-                  <a:txBody>
-                    <a:bodyPr/>
-                    <a:lstStyle/>
-                    <a:p>
-                      <a:pPr>
-                        <a:defRPr sz="1100">
-                          <a:solidFill>
-                            <a:srgbClr val="FFFFFF"/>
-                          </a:solidFill>
-                        </a:defRPr>
-                      </a:pPr>
-                      <a:r>
-                        <a:t>False Alarm Reduction</a:t>
-                      </a:r>
-                    </a:p>
-                  </a:txBody>
-                  <a:tcPr>
-                    <a:solidFill>
-                      <a:srgbClr val="111827"/>
-                    </a:solidFill>
-                  </a:tcPr>
-                </a:tc>
-                <a:tc>
-                  <a:txBody>
-                    <a:bodyPr/>
-                    <a:lstStyle/>
-                    <a:p>
-                      <a:pPr>
-                        <a:defRPr sz="1100">
-                          <a:solidFill>
-                            <a:srgbClr val="22C55E"/>
-                          </a:solidFill>
-                        </a:defRPr>
-                      </a:pPr>
-                      <a:r>
-                        <a:t>94.2%</a:t>
-                      </a:r>
-                    </a:p>
-                  </a:txBody>
-                  <a:tcPr>
-                    <a:solidFill>
-                      <a:srgbClr val="111827"/>
-                    </a:solidFill>
-                  </a:tcPr>
-                </a:tc>
-                <a:tc>
-                  <a:txBody>
-                    <a:bodyPr/>
-                    <a:lstStyle/>
-                    <a:p>
-                      <a:pPr>
-                        <a:defRPr sz="1100">
-                          <a:solidFill>
-                            <a:srgbClr val="9CA3AF"/>
-                          </a:solidFill>
-                        </a:defRPr>
-                      </a:pPr>
-                      <a:r>
-                        <a:t>Achieved via Decision Engine multi-layer consensus rules</a:t>
-                      </a:r>
-                    </a:p>
-                  </a:txBody>
-                  <a:tcPr>
-                    <a:solidFill>
-                      <a:srgbClr val="111827"/>
-                    </a:solidFill>
-                  </a:tcPr>
-                </a:tc>
-              </a:tr>
-              <a:tr h="514350">
-                <a:tc>
-                  <a:txBody>
-                    <a:bodyPr/>
-                    <a:lstStyle/>
-                    <a:p>
-                      <a:pPr>
-                        <a:defRPr sz="1100">
-                          <a:solidFill>
-                            <a:srgbClr val="FFFFFF"/>
-                          </a:solidFill>
-                        </a:defRPr>
-                      </a:pPr>
-                      <a:r>
-                        <a:t>Inference Latency</a:t>
-                      </a:r>
-                    </a:p>
-                  </a:txBody>
-                  <a:tcPr>
-                    <a:solidFill>
-                      <a:srgbClr val="111827"/>
-                    </a:solidFill>
-                  </a:tcPr>
-                </a:tc>
-                <a:tc>
-                  <a:txBody>
-                    <a:bodyPr/>
-                    <a:lstStyle/>
-                    <a:p>
-                      <a:pPr>
-                        <a:defRPr sz="1100">
-                          <a:solidFill>
-                            <a:srgbClr val="22C55E"/>
-                          </a:solidFill>
-                        </a:defRPr>
-                      </a:pPr>
-                      <a:r>
-                        <a:t>12.5 ms</a:t>
-                      </a:r>
-                    </a:p>
-                  </a:txBody>
-                  <a:tcPr>
-                    <a:solidFill>
-                      <a:srgbClr val="111827"/>
-                    </a:solidFill>
-                  </a:tcPr>
-                </a:tc>
-                <a:tc>
-                  <a:txBody>
-                    <a:bodyPr/>
-                    <a:lstStyle/>
-                    <a:p>
-                      <a:pPr>
-                        <a:defRPr sz="1100">
-                          <a:solidFill>
-                            <a:srgbClr val="9CA3AF"/>
-                          </a:solidFill>
-                        </a:defRPr>
-                      </a:pPr>
-                      <a:r>
-                        <a:t>Ultra-fast inference latency for real-time streaming ingestion</a:t>
-                      </a:r>
-                    </a:p>
-                  </a:txBody>
-                  <a:tcPr>
-                    <a:solidFill>
-                      <a:srgbClr val="111827"/>
-                    </a:solidFill>
-                  </a:tcPr>
-                </a:tc>
-              </a:tr>
-            </a:tbl>
-          </a:graphicData>
-        </a:graphic>
-      </p:graphicFrame>
+        </p:nvSpPr>
+        <p:spPr>
+          <a:xfrm>
+            <a:off x="731520" y="1463040"/>
+            <a:ext cx="5120640" cy="2194560"/>
+          </a:xfrm>
+          <a:prstGeom prst="roundRect">
+            <a:avLst/>
+          </a:prstGeom>
+          <a:solidFill>
+            <a:srgbClr val="111827"/>
+          </a:solidFill>
+          <a:ln>
+            <a:solidFill>
+              <a:srgbClr val="1F2937"/>
+            </a:solidFill>
+          </a:ln>
+        </p:spPr>
+        <p:style>
+          <a:lnRef idx="1">
+            <a:schemeClr val="accent1"/>
+          </a:lnRef>
+          <a:fillRef idx="3">
+            <a:schemeClr val="accent1"/>
+          </a:fillRef>
+          <a:effectRef idx="2">
+            <a:schemeClr val="accent1"/>
+          </a:effectRef>
+          <a:fontRef idx="minor">
+            <a:schemeClr val="lt1"/>
+          </a:fontRef>
+        </p:style>
+        <p:txBody>
+          <a:bodyPr rtlCol="0" anchor="ctr"/>
+          <a:lstStyle/>
+          <a:p>
+            <a:pPr algn="ctr">
+              <a:defRPr sz="1300" b="1">
+                <a:solidFill>
+                  <a:srgbClr val="3B82F6"/>
+                </a:solidFill>
+              </a:defRPr>
+            </a:pPr>
+            <a:r>
+              <a:t>MODEL A1 — ANOMALY DETECTION</a:t>
+            </a:r>
+          </a:p>
+          <a:p>
+            <a:pPr>
+              <a:defRPr sz="1000" b="1">
+                <a:solidFill>
+                  <a:srgbClr val="FFFFFF"/>
+                </a:solidFill>
+              </a:defRPr>
+            </a:pPr>
+            <a:r>
+              <a:t>Dataset Benchmark: SKAB / Paderborn</a:t>
+            </a:r>
+          </a:p>
+          <a:p>
+            <a:pPr>
+              <a:defRPr sz="1100">
+                <a:solidFill>
+                  <a:srgbClr val="9CA3AF"/>
+                </a:solidFill>
+              </a:defRPr>
+            </a:pPr>
+            <a:r>
+              <a:t>Precision: 100.0% (1.000)</a:t>
+            </a:r>
+            <a:br/>
+            <a:r>
+              <a:t>Recall: 88.64%</a:t>
+            </a:r>
+            <a:br/>
+            <a:r>
+              <a:t>Weighted F1: 91.3% (0.9126)</a:t>
+            </a:r>
+            <a:br/>
+            <a:r>
+              <a:t>ROC-AUC: 93.8% (0.9383)</a:t>
+            </a:r>
+          </a:p>
+        </p:txBody>
+      </p:sp>
+      <p:sp>
+        <p:nvSpPr>
+          <p:cNvPr id="6" name="Rounded Rectangle 5"/>
+          <p:cNvSpPr/>
+          <p:nvPr/>
+        </p:nvSpPr>
+        <p:spPr>
+          <a:xfrm>
+            <a:off x="6126480" y="1463040"/>
+            <a:ext cx="5120640" cy="2194560"/>
+          </a:xfrm>
+          <a:prstGeom prst="roundRect">
+            <a:avLst/>
+          </a:prstGeom>
+          <a:solidFill>
+            <a:srgbClr val="111827"/>
+          </a:solidFill>
+          <a:ln>
+            <a:solidFill>
+              <a:srgbClr val="1F2937"/>
+            </a:solidFill>
+          </a:ln>
+        </p:spPr>
+        <p:style>
+          <a:lnRef idx="1">
+            <a:schemeClr val="accent1"/>
+          </a:lnRef>
+          <a:fillRef idx="3">
+            <a:schemeClr val="accent1"/>
+          </a:fillRef>
+          <a:effectRef idx="2">
+            <a:schemeClr val="accent1"/>
+          </a:effectRef>
+          <a:fontRef idx="minor">
+            <a:schemeClr val="lt1"/>
+          </a:fontRef>
+        </p:style>
+        <p:txBody>
+          <a:bodyPr rtlCol="0" anchor="ctr"/>
+          <a:lstStyle/>
+          <a:p>
+            <a:pPr algn="ctr">
+              <a:defRPr sz="1300" b="1">
+                <a:solidFill>
+                  <a:srgbClr val="A855F7"/>
+                </a:solidFill>
+              </a:defRPr>
+            </a:pPr>
+            <a:r>
+              <a:t>MODEL A2 — FAULT CLASSIFIER</a:t>
+            </a:r>
+          </a:p>
+          <a:p>
+            <a:pPr>
+              <a:defRPr sz="1000" b="1">
+                <a:solidFill>
+                  <a:srgbClr val="FFFFFF"/>
+                </a:solidFill>
+              </a:defRPr>
+            </a:pPr>
+            <a:r>
+              <a:t>Dataset Benchmark: CWRU / Paderborn</a:t>
+            </a:r>
+          </a:p>
+          <a:p>
+            <a:pPr>
+              <a:defRPr sz="1100">
+                <a:solidFill>
+                  <a:srgbClr val="9CA3AF"/>
+                </a:solidFill>
+              </a:defRPr>
+            </a:pPr>
+            <a:r>
+              <a:t>Test Accuracy: 88.4%</a:t>
+            </a:r>
+            <a:br/>
+            <a:r>
+              <a:t>Weighted F1: 0.882</a:t>
+            </a:r>
+            <a:br/>
+            <a:r>
+              <a:t>Macro F1: 0.882</a:t>
+            </a:r>
+            <a:br/>
+            <a:r>
+              <a:t>Classes: 10 Bearing &amp; Motor Faults</a:t>
+            </a:r>
+          </a:p>
+        </p:txBody>
+      </p:sp>
+      <p:sp>
+        <p:nvSpPr>
+          <p:cNvPr id="7" name="Rounded Rectangle 6"/>
+          <p:cNvSpPr/>
+          <p:nvPr/>
+        </p:nvSpPr>
+        <p:spPr>
+          <a:xfrm>
+            <a:off x="731520" y="3840480"/>
+            <a:ext cx="5120640" cy="2194560"/>
+          </a:xfrm>
+          <a:prstGeom prst="roundRect">
+            <a:avLst/>
+          </a:prstGeom>
+          <a:solidFill>
+            <a:srgbClr val="111827"/>
+          </a:solidFill>
+          <a:ln>
+            <a:solidFill>
+              <a:srgbClr val="1F2937"/>
+            </a:solidFill>
+          </a:ln>
+        </p:spPr>
+        <p:style>
+          <a:lnRef idx="1">
+            <a:schemeClr val="accent1"/>
+          </a:lnRef>
+          <a:fillRef idx="3">
+            <a:schemeClr val="accent1"/>
+          </a:fillRef>
+          <a:effectRef idx="2">
+            <a:schemeClr val="accent1"/>
+          </a:effectRef>
+          <a:fontRef idx="minor">
+            <a:schemeClr val="lt1"/>
+          </a:fontRef>
+        </p:style>
+        <p:txBody>
+          <a:bodyPr rtlCol="0" anchor="ctr"/>
+          <a:lstStyle/>
+          <a:p>
+            <a:pPr algn="ctr">
+              <a:defRPr sz="1300" b="1">
+                <a:solidFill>
+                  <a:srgbClr val="F59E0B"/>
+                </a:solidFill>
+              </a:defRPr>
+            </a:pPr>
+            <a:r>
+              <a:t>MODEL B — RUL ESTIMATION</a:t>
+            </a:r>
+          </a:p>
+          <a:p>
+            <a:pPr>
+              <a:defRPr sz="1000" b="1">
+                <a:solidFill>
+                  <a:srgbClr val="FFFFFF"/>
+                </a:solidFill>
+              </a:defRPr>
+            </a:pPr>
+            <a:r>
+              <a:t>Dataset Benchmark: NASA CMAPSS FD001</a:t>
+            </a:r>
+          </a:p>
+          <a:p>
+            <a:pPr>
+              <a:defRPr sz="1100">
+                <a:solidFill>
+                  <a:srgbClr val="9CA3AF"/>
+                </a:solidFill>
+              </a:defRPr>
+            </a:pPr>
+            <a:r>
+              <a:t>MAE: 10.24 cycles / hours</a:t>
+            </a:r>
+            <a:br/>
+            <a:r>
+              <a:t>RMSE: 14.15 cycles / hours</a:t>
+            </a:r>
+            <a:br/>
+            <a:r>
+              <a:t>R² Score: 77.3% (0.7734)</a:t>
+            </a:r>
+            <a:br/>
+            <a:r>
+              <a:t>Early Ratio: 65.5% / Late: 34.5%</a:t>
+            </a:r>
+          </a:p>
+        </p:txBody>
+      </p:sp>
+      <p:sp>
+        <p:nvSpPr>
+          <p:cNvPr id="8" name="Rounded Rectangle 7"/>
+          <p:cNvSpPr/>
+          <p:nvPr/>
+        </p:nvSpPr>
+        <p:spPr>
+          <a:xfrm>
+            <a:off x="6126480" y="3840480"/>
+            <a:ext cx="5120640" cy="2194560"/>
+          </a:xfrm>
+          <a:prstGeom prst="roundRect">
+            <a:avLst/>
+          </a:prstGeom>
+          <a:solidFill>
+            <a:srgbClr val="111827"/>
+          </a:solidFill>
+          <a:ln>
+            <a:solidFill>
+              <a:srgbClr val="1F2937"/>
+            </a:solidFill>
+          </a:ln>
+        </p:spPr>
+        <p:style>
+          <a:lnRef idx="1">
+            <a:schemeClr val="accent1"/>
+          </a:lnRef>
+          <a:fillRef idx="3">
+            <a:schemeClr val="accent1"/>
+          </a:fillRef>
+          <a:effectRef idx="2">
+            <a:schemeClr val="accent1"/>
+          </a:effectRef>
+          <a:fontRef idx="minor">
+            <a:schemeClr val="lt1"/>
+          </a:fontRef>
+        </p:style>
+        <p:txBody>
+          <a:bodyPr rtlCol="0" anchor="ctr"/>
+          <a:lstStyle/>
+          <a:p>
+            <a:pPr algn="ctr">
+              <a:defRPr sz="1300" b="1">
+                <a:solidFill>
+                  <a:srgbClr val="22C55E"/>
+                </a:solidFill>
+              </a:defRPr>
+            </a:pPr>
+            <a:r>
+              <a:t>DECISION ENGINE</a:t>
+            </a:r>
+          </a:p>
+          <a:p>
+            <a:pPr>
+              <a:defRPr sz="1000" b="1">
+                <a:solidFill>
+                  <a:srgbClr val="FFFFFF"/>
+                </a:solidFill>
+              </a:defRPr>
+            </a:pPr>
+            <a:r>
+              <a:t>Dataset Benchmark: System Consensus</a:t>
+            </a:r>
+          </a:p>
+          <a:p>
+            <a:pPr>
+              <a:defRPr sz="1100">
+                <a:solidFill>
+                  <a:srgbClr val="9CA3AF"/>
+                </a:solidFill>
+              </a:defRPr>
+            </a:pPr>
+            <a:r>
+              <a:t>False Alarm Reduction: 94.2%</a:t>
+            </a:r>
+            <a:br/>
+            <a:r>
+              <a:t>System FPR: &lt; 1.2%</a:t>
+            </a:r>
+            <a:br/>
+            <a:r>
+              <a:t>Inference Latency: 12.5 ms</a:t>
+            </a:r>
+            <a:br/>
+            <a:r>
+              <a:t>Alert Cooldown: 100% Effective</a:t>
+            </a:r>
+          </a:p>
+        </p:txBody>
+      </p:sp>
     </p:spTree>
   </p:cSld>
   <p:clrMapOvr>

</xml_diff>